<commit_message>
feat(templates): restore operations cover image carrier
Add the style-specific documentary cover band and KPI hierarchy, then refresh the reference, native render, reuse, and hash evidence.
</commit_message>
<xml_diff>
--- a/skills/presentation-template-library/skills/artifact-template-blue-flame-operations/assets/reference.pptx
+++ b/skills/presentation-template-library/skills/artifact-template-blue-flame-operations/assets/reference.pptx
@@ -197,16 +197,6 @@
 <file path=ppt/slides/slide1.xml><?xml version="1.0" encoding="utf-8"?>
 <p:sld xmlns:p="http://schemas.openxmlformats.org/presentationml/2006/main">
   <p:cSld name="Opening claim">
-    <p:bg>
-      <p:bgPr>
-        <a:blipFill xmlns:a="http://schemas.openxmlformats.org/drawingml/2006/main">
-          <a:blip xmlns:r="http://schemas.openxmlformats.org/officeDocument/2006/relationships" r:embed="rIdOfficeKitImageb5a7d66fe0ba8bb7_1"/>
-          <a:stretch>
-            <a:fillRect/>
-          </a:stretch>
-        </a:blipFill>
-      </p:bgPr>
-    </p:bg>
     <p:spTree>
       <p:nvGrpSpPr>
         <p:cNvPr id="1" name=""/>
@@ -223,22 +213,20 @@
       </p:grpSpPr>
       <p:sp>
         <p:nvSpPr>
-          <p:cNvPr id="2" name="cover-paper-scrim"/>
+          <p:cNvPr id="2" name="blue-flame-cover-field"/>
           <p:cNvSpPr/>
           <p:nvPr/>
         </p:nvSpPr>
         <p:spPr>
           <a:xfrm xmlns:a="http://schemas.openxmlformats.org/drawingml/2006/main">
             <a:off x="0" y="0"/>
-            <a:ext cx="9525000" cy="8572500"/>
+            <a:ext cx="15240000" cy="8572500"/>
           </a:xfrm>
           <a:prstGeom xmlns:a="http://schemas.openxmlformats.org/drawingml/2006/main" prst="rect">
             <a:avLst/>
           </a:prstGeom>
           <a:solidFill xmlns:a="http://schemas.openxmlformats.org/drawingml/2006/main">
-            <a:srgbClr val="070A10">
-              <a:alpha val="100000"/>
-            </a:srgbClr>
+            <a:srgbClr val="070A10"/>
           </a:solidFill>
           <a:ln xmlns:a="http://schemas.openxmlformats.org/drawingml/2006/main" w="0">
             <a:solidFill>
@@ -261,420 +249,14 @@
       </p:sp>
       <p:sp>
         <p:nvSpPr>
-          <p:cNvPr id="3" name="fixed-rail"/>
+          <p:cNvPr id="3" name="blue-flame-cover-top-rule"/>
           <p:cNvSpPr/>
           <p:nvPr/>
         </p:nvSpPr>
         <p:spPr>
           <a:xfrm xmlns:a="http://schemas.openxmlformats.org/drawingml/2006/main">
-            <a:off x="323850" y="0"/>
-            <a:ext cx="114300" cy="8572500"/>
-          </a:xfrm>
-          <a:prstGeom xmlns:a="http://schemas.openxmlformats.org/drawingml/2006/main" prst="rect">
-            <a:avLst/>
-          </a:prstGeom>
-          <a:solidFill xmlns:a="http://schemas.openxmlformats.org/drawingml/2006/main">
-            <a:srgbClr val="20BBD8"/>
-          </a:solidFill>
-          <a:ln xmlns:a="http://schemas.openxmlformats.org/drawingml/2006/main" w="0">
-            <a:solidFill>
-              <a:srgbClr val="20BBD8"/>
-            </a:solidFill>
-            <a:prstDash val="solid"/>
-          </a:ln>
-        </p:spPr>
-        <p:txBody>
-          <a:bodyPr xmlns:a="http://schemas.openxmlformats.org/drawingml/2006/main" wrap="square" lIns="0" tIns="0" rIns="0" bIns="0" anchor="t"/>
-          <a:lstStyle xmlns:a="http://schemas.openxmlformats.org/drawingml/2006/main"/>
-          <a:p xmlns:a="http://schemas.openxmlformats.org/drawingml/2006/main">
-            <a:r>
-              <a:rPr lang="en-US"/>
-              <a:t/>
-            </a:r>
-            <a:endParaRPr lang="en-US"/>
-          </a:p>
-        </p:txBody>
-      </p:sp>
-      <p:sp>
-        <p:nvSpPr>
-          <p:cNvPr id="4" name="fixed-nav-0"/>
-          <p:cNvSpPr/>
-          <p:nvPr/>
-        </p:nvSpPr>
-        <p:spPr>
-          <a:xfrm xmlns:a="http://schemas.openxmlformats.org/drawingml/2006/main">
-            <a:off x="914400" y="4210050"/>
-            <a:ext cx="1516380" cy="209550"/>
-          </a:xfrm>
-          <a:prstGeom xmlns:a="http://schemas.openxmlformats.org/drawingml/2006/main" prst="rect">
-            <a:avLst/>
-          </a:prstGeom>
-          <a:solidFill xmlns:a="http://schemas.openxmlformats.org/drawingml/2006/main">
-            <a:srgbClr val="F2F6F8"/>
-          </a:solidFill>
-          <a:ln xmlns:a="http://schemas.openxmlformats.org/drawingml/2006/main" w="0">
-            <a:solidFill>
-              <a:srgbClr val="F2F6F8"/>
-            </a:solidFill>
-            <a:prstDash val="solid"/>
-          </a:ln>
-        </p:spPr>
-        <p:txBody>
-          <a:bodyPr xmlns:a="http://schemas.openxmlformats.org/drawingml/2006/main" wrap="square" lIns="0" tIns="0" rIns="0" bIns="0" anchor="t"/>
-          <a:lstStyle xmlns:a="http://schemas.openxmlformats.org/drawingml/2006/main"/>
-          <a:p xmlns:a="http://schemas.openxmlformats.org/drawingml/2006/main">
-            <a:r>
-              <a:rPr lang="en-US"/>
-              <a:t/>
-            </a:r>
-            <a:endParaRPr lang="en-US"/>
-          </a:p>
-        </p:txBody>
-      </p:sp>
-      <p:sp>
-        <p:nvSpPr>
-          <p:cNvPr id="5" name="fixed-nav-label-0"/>
-          <p:cNvSpPr txBox="1"/>
-          <p:nvPr/>
-        </p:nvSpPr>
-        <p:spPr>
-          <a:xfrm xmlns:a="http://schemas.openxmlformats.org/drawingml/2006/main">
-            <a:off x="990600" y="4248150"/>
-            <a:ext cx="1363980" cy="133350"/>
-          </a:xfrm>
-          <a:prstGeom xmlns:a="http://schemas.openxmlformats.org/drawingml/2006/main" prst="rect">
-            <a:avLst/>
-          </a:prstGeom>
-          <a:noFill xmlns:a="http://schemas.openxmlformats.org/drawingml/2006/main"/>
-          <a:ln xmlns:a="http://schemas.openxmlformats.org/drawingml/2006/main" w="0">
-            <a:noFill/>
-          </a:ln>
-        </p:spPr>
-        <p:txBody>
-          <a:bodyPr xmlns:a="http://schemas.openxmlformats.org/drawingml/2006/main" wrap="square" lIns="0" tIns="0" rIns="0" bIns="0" anchor="t"/>
-          <a:lstStyle xmlns:a="http://schemas.openxmlformats.org/drawingml/2006/main"/>
-          <a:p xmlns:a="http://schemas.openxmlformats.org/drawingml/2006/main">
-            <a:pPr algn="ctr"/>
-            <a:r>
-              <a:rPr lang="en-US" sz="675" b="1">
-                <a:solidFill>
-                  <a:srgbClr val="202124"/>
-                </a:solidFill>
-                <a:latin typeface="Inter"/>
-                <a:ea typeface="Inter"/>
-              </a:rPr>
-              <a:t>BRIEF</a:t>
-            </a:r>
-            <a:endParaRPr lang="en-US"/>
-          </a:p>
-        </p:txBody>
-      </p:sp>
-      <p:sp>
-        <p:nvSpPr>
-          <p:cNvPr id="6" name="fixed-nav-1"/>
-          <p:cNvSpPr/>
-          <p:nvPr/>
-        </p:nvSpPr>
-        <p:spPr>
-          <a:xfrm xmlns:a="http://schemas.openxmlformats.org/drawingml/2006/main">
-            <a:off x="2487930" y="4210050"/>
-            <a:ext cx="1516380" cy="209550"/>
-          </a:xfrm>
-          <a:prstGeom xmlns:a="http://schemas.openxmlformats.org/drawingml/2006/main" prst="rect">
-            <a:avLst/>
-          </a:prstGeom>
-          <a:solidFill xmlns:a="http://schemas.openxmlformats.org/drawingml/2006/main">
-            <a:srgbClr val="131A24"/>
-          </a:solidFill>
-          <a:ln xmlns:a="http://schemas.openxmlformats.org/drawingml/2006/main" w="0">
-            <a:solidFill>
-              <a:srgbClr val="131A24"/>
-            </a:solidFill>
-            <a:prstDash val="solid"/>
-          </a:ln>
-        </p:spPr>
-        <p:txBody>
-          <a:bodyPr xmlns:a="http://schemas.openxmlformats.org/drawingml/2006/main" wrap="square" lIns="0" tIns="0" rIns="0" bIns="0" anchor="t"/>
-          <a:lstStyle xmlns:a="http://schemas.openxmlformats.org/drawingml/2006/main"/>
-          <a:p xmlns:a="http://schemas.openxmlformats.org/drawingml/2006/main">
-            <a:r>
-              <a:rPr lang="en-US"/>
-              <a:t/>
-            </a:r>
-            <a:endParaRPr lang="en-US"/>
-          </a:p>
-        </p:txBody>
-      </p:sp>
-      <p:sp>
-        <p:nvSpPr>
-          <p:cNvPr id="7" name="fixed-nav-label-1"/>
-          <p:cNvSpPr txBox="1"/>
-          <p:nvPr/>
-        </p:nvSpPr>
-        <p:spPr>
-          <a:xfrm xmlns:a="http://schemas.openxmlformats.org/drawingml/2006/main">
-            <a:off x="2564130" y="4248150"/>
-            <a:ext cx="1363980" cy="133350"/>
-          </a:xfrm>
-          <a:prstGeom xmlns:a="http://schemas.openxmlformats.org/drawingml/2006/main" prst="rect">
-            <a:avLst/>
-          </a:prstGeom>
-          <a:noFill xmlns:a="http://schemas.openxmlformats.org/drawingml/2006/main"/>
-          <a:ln xmlns:a="http://schemas.openxmlformats.org/drawingml/2006/main" w="0">
-            <a:noFill/>
-          </a:ln>
-        </p:spPr>
-        <p:txBody>
-          <a:bodyPr xmlns:a="http://schemas.openxmlformats.org/drawingml/2006/main" wrap="square" lIns="0" tIns="0" rIns="0" bIns="0" anchor="t"/>
-          <a:lstStyle xmlns:a="http://schemas.openxmlformats.org/drawingml/2006/main"/>
-          <a:p xmlns:a="http://schemas.openxmlformats.org/drawingml/2006/main">
-            <a:pPr algn="ctr"/>
-            <a:r>
-              <a:rPr lang="en-US" sz="675" b="1">
-                <a:solidFill>
-                  <a:srgbClr val="787B7F"/>
-                </a:solidFill>
-                <a:latin typeface="Inter"/>
-                <a:ea typeface="Inter"/>
-              </a:rPr>
-              <a:t>SIGNAL</a:t>
-            </a:r>
-            <a:endParaRPr lang="en-US"/>
-          </a:p>
-        </p:txBody>
-      </p:sp>
-      <p:sp>
-        <p:nvSpPr>
-          <p:cNvPr id="8" name="fixed-nav-2"/>
-          <p:cNvSpPr/>
-          <p:nvPr/>
-        </p:nvSpPr>
-        <p:spPr>
-          <a:xfrm xmlns:a="http://schemas.openxmlformats.org/drawingml/2006/main">
-            <a:off x="4061460" y="4210050"/>
-            <a:ext cx="1516380" cy="209550"/>
-          </a:xfrm>
-          <a:prstGeom xmlns:a="http://schemas.openxmlformats.org/drawingml/2006/main" prst="rect">
-            <a:avLst/>
-          </a:prstGeom>
-          <a:solidFill xmlns:a="http://schemas.openxmlformats.org/drawingml/2006/main">
-            <a:srgbClr val="131A24"/>
-          </a:solidFill>
-          <a:ln xmlns:a="http://schemas.openxmlformats.org/drawingml/2006/main" w="0">
-            <a:solidFill>
-              <a:srgbClr val="131A24"/>
-            </a:solidFill>
-            <a:prstDash val="solid"/>
-          </a:ln>
-        </p:spPr>
-        <p:txBody>
-          <a:bodyPr xmlns:a="http://schemas.openxmlformats.org/drawingml/2006/main" wrap="square" lIns="0" tIns="0" rIns="0" bIns="0" anchor="t"/>
-          <a:lstStyle xmlns:a="http://schemas.openxmlformats.org/drawingml/2006/main"/>
-          <a:p xmlns:a="http://schemas.openxmlformats.org/drawingml/2006/main">
-            <a:r>
-              <a:rPr lang="en-US"/>
-              <a:t/>
-            </a:r>
-            <a:endParaRPr lang="en-US"/>
-          </a:p>
-        </p:txBody>
-      </p:sp>
-      <p:sp>
-        <p:nvSpPr>
-          <p:cNvPr id="9" name="fixed-nav-label-2"/>
-          <p:cNvSpPr txBox="1"/>
-          <p:nvPr/>
-        </p:nvSpPr>
-        <p:spPr>
-          <a:xfrm xmlns:a="http://schemas.openxmlformats.org/drawingml/2006/main">
-            <a:off x="4137660" y="4248150"/>
-            <a:ext cx="1363980" cy="133350"/>
-          </a:xfrm>
-          <a:prstGeom xmlns:a="http://schemas.openxmlformats.org/drawingml/2006/main" prst="rect">
-            <a:avLst/>
-          </a:prstGeom>
-          <a:noFill xmlns:a="http://schemas.openxmlformats.org/drawingml/2006/main"/>
-          <a:ln xmlns:a="http://schemas.openxmlformats.org/drawingml/2006/main" w="0">
-            <a:noFill/>
-          </a:ln>
-        </p:spPr>
-        <p:txBody>
-          <a:bodyPr xmlns:a="http://schemas.openxmlformats.org/drawingml/2006/main" wrap="square" lIns="0" tIns="0" rIns="0" bIns="0" anchor="t"/>
-          <a:lstStyle xmlns:a="http://schemas.openxmlformats.org/drawingml/2006/main"/>
-          <a:p xmlns:a="http://schemas.openxmlformats.org/drawingml/2006/main">
-            <a:pPr algn="ctr"/>
-            <a:r>
-              <a:rPr lang="en-US" sz="675" b="1">
-                <a:solidFill>
-                  <a:srgbClr val="787B7F"/>
-                </a:solidFill>
-                <a:latin typeface="Inter"/>
-                <a:ea typeface="Inter"/>
-              </a:rPr>
-              <a:t>EVIDENCE</a:t>
-            </a:r>
-            <a:endParaRPr lang="en-US"/>
-          </a:p>
-        </p:txBody>
-      </p:sp>
-      <p:sp>
-        <p:nvSpPr>
-          <p:cNvPr id="10" name="fixed-nav-3"/>
-          <p:cNvSpPr/>
-          <p:nvPr/>
-        </p:nvSpPr>
-        <p:spPr>
-          <a:xfrm xmlns:a="http://schemas.openxmlformats.org/drawingml/2006/main">
-            <a:off x="5634990" y="4210050"/>
-            <a:ext cx="1516380" cy="209550"/>
-          </a:xfrm>
-          <a:prstGeom xmlns:a="http://schemas.openxmlformats.org/drawingml/2006/main" prst="rect">
-            <a:avLst/>
-          </a:prstGeom>
-          <a:solidFill xmlns:a="http://schemas.openxmlformats.org/drawingml/2006/main">
-            <a:srgbClr val="131A24"/>
-          </a:solidFill>
-          <a:ln xmlns:a="http://schemas.openxmlformats.org/drawingml/2006/main" w="0">
-            <a:solidFill>
-              <a:srgbClr val="131A24"/>
-            </a:solidFill>
-            <a:prstDash val="solid"/>
-          </a:ln>
-        </p:spPr>
-        <p:txBody>
-          <a:bodyPr xmlns:a="http://schemas.openxmlformats.org/drawingml/2006/main" wrap="square" lIns="0" tIns="0" rIns="0" bIns="0" anchor="t"/>
-          <a:lstStyle xmlns:a="http://schemas.openxmlformats.org/drawingml/2006/main"/>
-          <a:p xmlns:a="http://schemas.openxmlformats.org/drawingml/2006/main">
-            <a:r>
-              <a:rPr lang="en-US"/>
-              <a:t/>
-            </a:r>
-            <a:endParaRPr lang="en-US"/>
-          </a:p>
-        </p:txBody>
-      </p:sp>
-      <p:sp>
-        <p:nvSpPr>
-          <p:cNvPr id="11" name="fixed-nav-label-3"/>
-          <p:cNvSpPr txBox="1"/>
-          <p:nvPr/>
-        </p:nvSpPr>
-        <p:spPr>
-          <a:xfrm xmlns:a="http://schemas.openxmlformats.org/drawingml/2006/main">
-            <a:off x="5711190" y="4248150"/>
-            <a:ext cx="1363980" cy="133350"/>
-          </a:xfrm>
-          <a:prstGeom xmlns:a="http://schemas.openxmlformats.org/drawingml/2006/main" prst="rect">
-            <a:avLst/>
-          </a:prstGeom>
-          <a:noFill xmlns:a="http://schemas.openxmlformats.org/drawingml/2006/main"/>
-          <a:ln xmlns:a="http://schemas.openxmlformats.org/drawingml/2006/main" w="0">
-            <a:noFill/>
-          </a:ln>
-        </p:spPr>
-        <p:txBody>
-          <a:bodyPr xmlns:a="http://schemas.openxmlformats.org/drawingml/2006/main" wrap="square" lIns="0" tIns="0" rIns="0" bIns="0" anchor="t"/>
-          <a:lstStyle xmlns:a="http://schemas.openxmlformats.org/drawingml/2006/main"/>
-          <a:p xmlns:a="http://schemas.openxmlformats.org/drawingml/2006/main">
-            <a:pPr algn="ctr"/>
-            <a:r>
-              <a:rPr lang="en-US" sz="675" b="1">
-                <a:solidFill>
-                  <a:srgbClr val="787B7F"/>
-                </a:solidFill>
-                <a:latin typeface="Inter"/>
-                <a:ea typeface="Inter"/>
-              </a:rPr>
-              <a:t>CHOICE</a:t>
-            </a:r>
-            <a:endParaRPr lang="en-US"/>
-          </a:p>
-        </p:txBody>
-      </p:sp>
-      <p:sp>
-        <p:nvSpPr>
-          <p:cNvPr id="12" name="fixed-nav-4"/>
-          <p:cNvSpPr/>
-          <p:nvPr/>
-        </p:nvSpPr>
-        <p:spPr>
-          <a:xfrm xmlns:a="http://schemas.openxmlformats.org/drawingml/2006/main">
-            <a:off x="7208520" y="4210050"/>
-            <a:ext cx="1516380" cy="209550"/>
-          </a:xfrm>
-          <a:prstGeom xmlns:a="http://schemas.openxmlformats.org/drawingml/2006/main" prst="rect">
-            <a:avLst/>
-          </a:prstGeom>
-          <a:solidFill xmlns:a="http://schemas.openxmlformats.org/drawingml/2006/main">
-            <a:srgbClr val="131A24"/>
-          </a:solidFill>
-          <a:ln xmlns:a="http://schemas.openxmlformats.org/drawingml/2006/main" w="0">
-            <a:solidFill>
-              <a:srgbClr val="131A24"/>
-            </a:solidFill>
-            <a:prstDash val="solid"/>
-          </a:ln>
-        </p:spPr>
-        <p:txBody>
-          <a:bodyPr xmlns:a="http://schemas.openxmlformats.org/drawingml/2006/main" wrap="square" lIns="0" tIns="0" rIns="0" bIns="0" anchor="t"/>
-          <a:lstStyle xmlns:a="http://schemas.openxmlformats.org/drawingml/2006/main"/>
-          <a:p xmlns:a="http://schemas.openxmlformats.org/drawingml/2006/main">
-            <a:r>
-              <a:rPr lang="en-US"/>
-              <a:t/>
-            </a:r>
-            <a:endParaRPr lang="en-US"/>
-          </a:p>
-        </p:txBody>
-      </p:sp>
-      <p:sp>
-        <p:nvSpPr>
-          <p:cNvPr id="13" name="fixed-nav-label-4"/>
-          <p:cNvSpPr txBox="1"/>
-          <p:nvPr/>
-        </p:nvSpPr>
-        <p:spPr>
-          <a:xfrm xmlns:a="http://schemas.openxmlformats.org/drawingml/2006/main">
-            <a:off x="7284720" y="4248150"/>
-            <a:ext cx="1363980" cy="133350"/>
-          </a:xfrm>
-          <a:prstGeom xmlns:a="http://schemas.openxmlformats.org/drawingml/2006/main" prst="rect">
-            <a:avLst/>
-          </a:prstGeom>
-          <a:noFill xmlns:a="http://schemas.openxmlformats.org/drawingml/2006/main"/>
-          <a:ln xmlns:a="http://schemas.openxmlformats.org/drawingml/2006/main" w="0">
-            <a:noFill/>
-          </a:ln>
-        </p:spPr>
-        <p:txBody>
-          <a:bodyPr xmlns:a="http://schemas.openxmlformats.org/drawingml/2006/main" wrap="square" lIns="0" tIns="0" rIns="0" bIns="0" anchor="t"/>
-          <a:lstStyle xmlns:a="http://schemas.openxmlformats.org/drawingml/2006/main"/>
-          <a:p xmlns:a="http://schemas.openxmlformats.org/drawingml/2006/main">
-            <a:pPr algn="ctr"/>
-            <a:r>
-              <a:rPr lang="en-US" sz="675" b="1">
-                <a:solidFill>
-                  <a:srgbClr val="787B7F"/>
-                </a:solidFill>
-                <a:latin typeface="Inter"/>
-                <a:ea typeface="Inter"/>
-              </a:rPr>
-              <a:t>NEXT</a:t>
-            </a:r>
-            <a:endParaRPr lang="en-US"/>
-          </a:p>
-        </p:txBody>
-      </p:sp>
-      <p:sp>
-        <p:nvSpPr>
-          <p:cNvPr id="14" name="top-rule"/>
-          <p:cNvSpPr/>
-          <p:nvPr/>
-        </p:nvSpPr>
-        <p:spPr>
-          <a:xfrm xmlns:a="http://schemas.openxmlformats.org/drawingml/2006/main">
-            <a:off x="838200" y="666750"/>
-            <a:ext cx="13563600" cy="0"/>
+            <a:off x="914400" y="419100"/>
+            <a:ext cx="13411200" cy="0"/>
           </a:xfrm>
           <a:prstGeom xmlns:a="http://schemas.openxmlformats.org/drawingml/2006/main" prst="line">
             <a:avLst/>
@@ -701,29 +283,29 @@
       </p:sp>
       <p:sp>
         <p:nvSpPr>
-          <p:cNvPr id="15" name="eyebrow"/>
-          <p:cNvSpPr txBox="1"/>
-          <p:nvPr/>
-        </p:nvSpPr>
-        <p:spPr>
-          <a:xfrm xmlns:a="http://schemas.openxmlformats.org/drawingml/2006/main">
-            <a:off x="914400" y="895350"/>
-            <a:ext cx="7239000" cy="228600"/>
-          </a:xfrm>
-          <a:prstGeom xmlns:a="http://schemas.openxmlformats.org/drawingml/2006/main" prst="rect">
-            <a:avLst/>
-          </a:prstGeom>
-          <a:noFill xmlns:a="http://schemas.openxmlformats.org/drawingml/2006/main"/>
-          <a:ln xmlns:a="http://schemas.openxmlformats.org/drawingml/2006/main" w="0">
-            <a:noFill/>
-          </a:ln>
-        </p:spPr>
-        <p:txBody>
-          <a:bodyPr xmlns:a="http://schemas.openxmlformats.org/drawingml/2006/main" wrap="square" lIns="0" tIns="0" rIns="0" bIns="0" anchor="t"/>
-          <a:lstStyle xmlns:a="http://schemas.openxmlformats.org/drawingml/2006/main"/>
-          <a:p xmlns:a="http://schemas.openxmlformats.org/drawingml/2006/main">
-            <a:r>
-              <a:rPr lang="en-US" sz="1200" b="1">
+          <p:cNvPr id="4" name="blue-flame-cover-eyebrow"/>
+          <p:cNvSpPr txBox="1"/>
+          <p:nvPr/>
+        </p:nvSpPr>
+        <p:spPr>
+          <a:xfrm xmlns:a="http://schemas.openxmlformats.org/drawingml/2006/main">
+            <a:off x="914400" y="628650"/>
+            <a:ext cx="7239000" cy="209550"/>
+          </a:xfrm>
+          <a:prstGeom xmlns:a="http://schemas.openxmlformats.org/drawingml/2006/main" prst="rect">
+            <a:avLst/>
+          </a:prstGeom>
+          <a:noFill xmlns:a="http://schemas.openxmlformats.org/drawingml/2006/main"/>
+          <a:ln xmlns:a="http://schemas.openxmlformats.org/drawingml/2006/main" w="0">
+            <a:noFill/>
+          </a:ln>
+        </p:spPr>
+        <p:txBody>
+          <a:bodyPr xmlns:a="http://schemas.openxmlformats.org/drawingml/2006/main" wrap="square" lIns="0" tIns="0" rIns="0" bIns="0" anchor="t"/>
+          <a:lstStyle xmlns:a="http://schemas.openxmlformats.org/drawingml/2006/main"/>
+          <a:p xmlns:a="http://schemas.openxmlformats.org/drawingml/2006/main">
+            <a:r>
+              <a:rPr lang="en-US" sz="1050" b="1">
                 <a:solidFill>
                   <a:srgbClr val="20BBD8"/>
                 </a:solidFill>
@@ -738,29 +320,29 @@
       </p:sp>
       <p:sp>
         <p:nvSpPr>
-          <p:cNvPr id="16" name="cover-title"/>
-          <p:cNvSpPr txBox="1"/>
-          <p:nvPr/>
-        </p:nvSpPr>
-        <p:spPr>
-          <a:xfrm xmlns:a="http://schemas.openxmlformats.org/drawingml/2006/main">
-            <a:off x="914400" y="1571625"/>
-            <a:ext cx="8382000" cy="1066800"/>
-          </a:xfrm>
-          <a:prstGeom xmlns:a="http://schemas.openxmlformats.org/drawingml/2006/main" prst="rect">
-            <a:avLst/>
-          </a:prstGeom>
-          <a:noFill xmlns:a="http://schemas.openxmlformats.org/drawingml/2006/main"/>
-          <a:ln xmlns:a="http://schemas.openxmlformats.org/drawingml/2006/main" w="0">
-            <a:noFill/>
-          </a:ln>
-        </p:spPr>
-        <p:txBody>
-          <a:bodyPr xmlns:a="http://schemas.openxmlformats.org/drawingml/2006/main" wrap="square" lIns="0" tIns="0" rIns="0" bIns="0" anchor="t"/>
-          <a:lstStyle xmlns:a="http://schemas.openxmlformats.org/drawingml/2006/main"/>
-          <a:p xmlns:a="http://schemas.openxmlformats.org/drawingml/2006/main">
-            <a:r>
-              <a:rPr lang="en-US" sz="3600" b="1">
+          <p:cNvPr id="5" name="cover-title"/>
+          <p:cNvSpPr txBox="1"/>
+          <p:nvPr/>
+        </p:nvSpPr>
+        <p:spPr>
+          <a:xfrm xmlns:a="http://schemas.openxmlformats.org/drawingml/2006/main">
+            <a:off x="914400" y="1009650"/>
+            <a:ext cx="10668000" cy="609600"/>
+          </a:xfrm>
+          <a:prstGeom xmlns:a="http://schemas.openxmlformats.org/drawingml/2006/main" prst="rect">
+            <a:avLst/>
+          </a:prstGeom>
+          <a:noFill xmlns:a="http://schemas.openxmlformats.org/drawingml/2006/main"/>
+          <a:ln xmlns:a="http://schemas.openxmlformats.org/drawingml/2006/main" w="0">
+            <a:noFill/>
+          </a:ln>
+        </p:spPr>
+        <p:txBody>
+          <a:bodyPr xmlns:a="http://schemas.openxmlformats.org/drawingml/2006/main" wrap="square" lIns="0" tIns="0" rIns="0" bIns="0" anchor="t"/>
+          <a:lstStyle xmlns:a="http://schemas.openxmlformats.org/drawingml/2006/main"/>
+          <a:p xmlns:a="http://schemas.openxmlformats.org/drawingml/2006/main">
+            <a:r>
+              <a:rPr lang="en-US" sz="2850" b="1">
                 <a:solidFill>
                   <a:srgbClr val="F2F6F8"/>
                 </a:solidFill>
@@ -775,57 +357,131 @@
       </p:sp>
       <p:sp>
         <p:nvSpPr>
-          <p:cNvPr id="17" name="cover-subtitle"/>
-          <p:cNvSpPr txBox="1"/>
-          <p:nvPr/>
-        </p:nvSpPr>
-        <p:spPr>
-          <a:xfrm xmlns:a="http://schemas.openxmlformats.org/drawingml/2006/main">
-            <a:off x="952500" y="2857500"/>
-            <a:ext cx="6858000" cy="323850"/>
-          </a:xfrm>
-          <a:prstGeom xmlns:a="http://schemas.openxmlformats.org/drawingml/2006/main" prst="rect">
-            <a:avLst/>
-          </a:prstGeom>
-          <a:noFill xmlns:a="http://schemas.openxmlformats.org/drawingml/2006/main"/>
-          <a:ln xmlns:a="http://schemas.openxmlformats.org/drawingml/2006/main" w="0">
-            <a:noFill/>
-          </a:ln>
-        </p:spPr>
-        <p:txBody>
-          <a:bodyPr xmlns:a="http://schemas.openxmlformats.org/drawingml/2006/main" wrap="square" lIns="0" tIns="0" rIns="0" bIns="0" anchor="t"/>
-          <a:lstStyle xmlns:a="http://schemas.openxmlformats.org/drawingml/2006/main"/>
-          <a:p xmlns:a="http://schemas.openxmlformats.org/drawingml/2006/main">
-            <a:r>
-              <a:rPr lang="en-US" sz="1725">
+          <p:cNvPr id="6" name="blue-flame-cover-basis"/>
+          <p:cNvSpPr txBox="1"/>
+          <p:nvPr/>
+        </p:nvSpPr>
+        <p:spPr>
+          <a:xfrm xmlns:a="http://schemas.openxmlformats.org/drawingml/2006/main">
+            <a:off x="952500" y="1657350"/>
+            <a:ext cx="8763000" cy="247650"/>
+          </a:xfrm>
+          <a:prstGeom xmlns:a="http://schemas.openxmlformats.org/drawingml/2006/main" prst="rect">
+            <a:avLst/>
+          </a:prstGeom>
+          <a:noFill xmlns:a="http://schemas.openxmlformats.org/drawingml/2006/main"/>
+          <a:ln xmlns:a="http://schemas.openxmlformats.org/drawingml/2006/main" w="0">
+            <a:noFill/>
+          </a:ln>
+        </p:spPr>
+        <p:txBody>
+          <a:bodyPr xmlns:a="http://schemas.openxmlformats.org/drawingml/2006/main" wrap="square" lIns="0" tIns="0" rIns="0" bIns="0" anchor="t"/>
+          <a:lstStyle xmlns:a="http://schemas.openxmlformats.org/drawingml/2006/main"/>
+          <a:p xmlns:a="http://schemas.openxmlformats.org/drawingml/2006/main">
+            <a:r>
+              <a:rPr lang="en-US" sz="1275">
+                <a:solidFill>
+                  <a:srgbClr val="787B7F"/>
+                </a:solidFill>
+                <a:latin typeface="Inter"/>
+                <a:ea typeface="Inter"/>
+              </a:rPr>
+              <a:t>A late-night operating review turns signal into a bounded next move.</a:t>
+            </a:r>
+            <a:endParaRPr lang="en-US"/>
+          </a:p>
+        </p:txBody>
+      </p:sp>
+      <p:sp>
+        <p:nvSpPr>
+          <p:cNvPr id="7" name="blue-flame-kpi-value-0"/>
+          <p:cNvSpPr txBox="1"/>
+          <p:nvPr/>
+        </p:nvSpPr>
+        <p:spPr>
+          <a:xfrm xmlns:a="http://schemas.openxmlformats.org/drawingml/2006/main">
+            <a:off x="952500" y="2076450"/>
+            <a:ext cx="2000250" cy="361950"/>
+          </a:xfrm>
+          <a:prstGeom xmlns:a="http://schemas.openxmlformats.org/drawingml/2006/main" prst="rect">
+            <a:avLst/>
+          </a:prstGeom>
+          <a:noFill xmlns:a="http://schemas.openxmlformats.org/drawingml/2006/main"/>
+          <a:ln xmlns:a="http://schemas.openxmlformats.org/drawingml/2006/main" w="0">
+            <a:noFill/>
+          </a:ln>
+        </p:spPr>
+        <p:txBody>
+          <a:bodyPr xmlns:a="http://schemas.openxmlformats.org/drawingml/2006/main" wrap="square" lIns="0" tIns="0" rIns="0" bIns="0" anchor="t"/>
+          <a:lstStyle xmlns:a="http://schemas.openxmlformats.org/drawingml/2006/main"/>
+          <a:p xmlns:a="http://schemas.openxmlformats.org/drawingml/2006/main">
+            <a:r>
+              <a:rPr lang="en-US" sz="2100" b="1">
                 <a:solidFill>
                   <a:srgbClr val="20BBD8"/>
                 </a:solidFill>
                 <a:latin typeface="Inter"/>
                 <a:ea typeface="Inter"/>
               </a:rPr>
-              <a:t>A clean-room reference for evidence, direction, and a decision.</a:t>
-            </a:r>
-            <a:endParaRPr lang="en-US"/>
-          </a:p>
-        </p:txBody>
-      </p:sp>
-      <p:sp>
-        <p:nvSpPr>
-          <p:cNvPr id="18" name="cover-rule"/>
+              <a:t>3.26m</a:t>
+            </a:r>
+            <a:endParaRPr lang="en-US"/>
+          </a:p>
+        </p:txBody>
+      </p:sp>
+      <p:sp>
+        <p:nvSpPr>
+          <p:cNvPr id="8" name="blue-flame-kpi-label-0"/>
+          <p:cNvSpPr txBox="1"/>
+          <p:nvPr/>
+        </p:nvSpPr>
+        <p:spPr>
+          <a:xfrm xmlns:a="http://schemas.openxmlformats.org/drawingml/2006/main">
+            <a:off x="952500" y="2457450"/>
+            <a:ext cx="2000250" cy="190500"/>
+          </a:xfrm>
+          <a:prstGeom xmlns:a="http://schemas.openxmlformats.org/drawingml/2006/main" prst="rect">
+            <a:avLst/>
+          </a:prstGeom>
+          <a:noFill xmlns:a="http://schemas.openxmlformats.org/drawingml/2006/main"/>
+          <a:ln xmlns:a="http://schemas.openxmlformats.org/drawingml/2006/main" w="0">
+            <a:noFill/>
+          </a:ln>
+        </p:spPr>
+        <p:txBody>
+          <a:bodyPr xmlns:a="http://schemas.openxmlformats.org/drawingml/2006/main" wrap="square" lIns="0" tIns="0" rIns="0" bIns="0" anchor="t"/>
+          <a:lstStyle xmlns:a="http://schemas.openxmlformats.org/drawingml/2006/main"/>
+          <a:p xmlns:a="http://schemas.openxmlformats.org/drawingml/2006/main">
+            <a:r>
+              <a:rPr lang="en-US" sz="975">
+                <a:solidFill>
+                  <a:srgbClr val="787B7F"/>
+                </a:solidFill>
+                <a:latin typeface="Inter"/>
+                <a:ea typeface="Inter"/>
+              </a:rPr>
+              <a:t>orders observed</a:t>
+            </a:r>
+            <a:endParaRPr lang="en-US"/>
+          </a:p>
+        </p:txBody>
+      </p:sp>
+      <p:sp>
+        <p:nvSpPr>
+          <p:cNvPr id="9" name="blue-flame-kpi-rule-0"/>
           <p:cNvSpPr/>
           <p:nvPr/>
         </p:nvSpPr>
         <p:spPr>
           <a:xfrm xmlns:a="http://schemas.openxmlformats.org/drawingml/2006/main">
-            <a:off x="914400" y="3524250"/>
-            <a:ext cx="7658100" cy="0"/>
+            <a:off x="3162300" y="2038350"/>
+            <a:ext cx="0" cy="609600"/>
           </a:xfrm>
           <a:prstGeom xmlns:a="http://schemas.openxmlformats.org/drawingml/2006/main" prst="line">
             <a:avLst/>
           </a:prstGeom>
           <a:noFill xmlns:a="http://schemas.openxmlformats.org/drawingml/2006/main"/>
-          <a:ln xmlns:a="http://schemas.openxmlformats.org/drawingml/2006/main" w="25400">
+          <a:ln xmlns:a="http://schemas.openxmlformats.org/drawingml/2006/main" w="12700">
             <a:solidFill>
               <a:srgbClr val="787B7F"/>
             </a:solidFill>
@@ -846,173 +502,96 @@
       </p:sp>
       <p:sp>
         <p:nvSpPr>
-          <p:cNvPr id="19" name="cover-basis"/>
-          <p:cNvSpPr txBox="1"/>
-          <p:nvPr/>
-        </p:nvSpPr>
-        <p:spPr>
-          <a:xfrm xmlns:a="http://schemas.openxmlformats.org/drawingml/2006/main">
-            <a:off x="952500" y="3762375"/>
-            <a:ext cx="7810500" cy="266700"/>
-          </a:xfrm>
-          <a:prstGeom xmlns:a="http://schemas.openxmlformats.org/drawingml/2006/main" prst="rect">
-            <a:avLst/>
-          </a:prstGeom>
-          <a:noFill xmlns:a="http://schemas.openxmlformats.org/drawingml/2006/main"/>
-          <a:ln xmlns:a="http://schemas.openxmlformats.org/drawingml/2006/main" w="0">
-            <a:noFill/>
-          </a:ln>
-        </p:spPr>
-        <p:txBody>
-          <a:bodyPr xmlns:a="http://schemas.openxmlformats.org/drawingml/2006/main" wrap="square" lIns="0" tIns="0" rIns="0" bIns="0" anchor="t"/>
-          <a:lstStyle xmlns:a="http://schemas.openxmlformats.org/drawingml/2006/main"/>
-          <a:p xmlns:a="http://schemas.openxmlformats.org/drawingml/2006/main">
-            <a:r>
-              <a:rPr lang="en-US" sz="1350">
+          <p:cNvPr id="10" name="blue-flame-kpi-value-1"/>
+          <p:cNvSpPr txBox="1"/>
+          <p:nvPr/>
+        </p:nvSpPr>
+        <p:spPr>
+          <a:xfrm xmlns:a="http://schemas.openxmlformats.org/drawingml/2006/main">
+            <a:off x="3524250" y="2076450"/>
+            <a:ext cx="2000250" cy="361950"/>
+          </a:xfrm>
+          <a:prstGeom xmlns:a="http://schemas.openxmlformats.org/drawingml/2006/main" prst="rect">
+            <a:avLst/>
+          </a:prstGeom>
+          <a:noFill xmlns:a="http://schemas.openxmlformats.org/drawingml/2006/main"/>
+          <a:ln xmlns:a="http://schemas.openxmlformats.org/drawingml/2006/main" w="0">
+            <a:noFill/>
+          </a:ln>
+        </p:spPr>
+        <p:txBody>
+          <a:bodyPr xmlns:a="http://schemas.openxmlformats.org/drawingml/2006/main" wrap="square" lIns="0" tIns="0" rIns="0" bIns="0" anchor="t"/>
+          <a:lstStyle xmlns:a="http://schemas.openxmlformats.org/drawingml/2006/main"/>
+          <a:p xmlns:a="http://schemas.openxmlformats.org/drawingml/2006/main">
+            <a:r>
+              <a:rPr lang="en-US" sz="2100" b="1">
                 <a:solidFill>
                   <a:srgbClr val="F2F6F8"/>
                 </a:solidFill>
                 <a:latin typeface="Inter"/>
                 <a:ea typeface="Inter"/>
               </a:rPr>
-              <a:t>One visual language · four page roles · native editable objects</a:t>
-            </a:r>
-            <a:endParaRPr lang="en-US"/>
-          </a:p>
-        </p:txBody>
-      </p:sp>
-      <p:sp>
-        <p:nvSpPr>
-          <p:cNvPr id="20" name="cover-thesis"/>
-          <p:cNvSpPr txBox="1"/>
-          <p:nvPr/>
-        </p:nvSpPr>
-        <p:spPr>
-          <a:xfrm xmlns:a="http://schemas.openxmlformats.org/drawingml/2006/main">
-            <a:off x="952500" y="4810125"/>
-            <a:ext cx="6667500" cy="628650"/>
-          </a:xfrm>
-          <a:prstGeom xmlns:a="http://schemas.openxmlformats.org/drawingml/2006/main" prst="rect">
-            <a:avLst/>
-          </a:prstGeom>
-          <a:noFill xmlns:a="http://schemas.openxmlformats.org/drawingml/2006/main"/>
-          <a:ln xmlns:a="http://schemas.openxmlformats.org/drawingml/2006/main" w="0">
-            <a:noFill/>
-          </a:ln>
-        </p:spPr>
-        <p:txBody>
-          <a:bodyPr xmlns:a="http://schemas.openxmlformats.org/drawingml/2006/main" wrap="square" lIns="0" tIns="0" rIns="0" bIns="0" anchor="t"/>
-          <a:lstStyle xmlns:a="http://schemas.openxmlformats.org/drawingml/2006/main"/>
-          <a:p xmlns:a="http://schemas.openxmlformats.org/drawingml/2006/main">
-            <a:r>
-              <a:rPr lang="en-US" sz="1875" b="1">
-                <a:solidFill>
-                  <a:srgbClr val="F2F6F8"/>
-                </a:solidFill>
-                <a:latin typeface="Inter"/>
-                <a:ea typeface="Inter"/>
-              </a:rPr>
-              <a:t>A visible operating signal creates a shared next action.</a:t>
-            </a:r>
-            <a:endParaRPr lang="en-US"/>
-          </a:p>
-        </p:txBody>
-      </p:sp>
-      <p:sp>
-        <p:nvSpPr>
-          <p:cNvPr id="21" name="cover-source"/>
-          <p:cNvSpPr txBox="1"/>
-          <p:nvPr/>
-        </p:nvSpPr>
-        <p:spPr>
-          <a:xfrm xmlns:a="http://schemas.openxmlformats.org/drawingml/2006/main">
-            <a:off x="952500" y="7315200"/>
-            <a:ext cx="9048750" cy="228600"/>
-          </a:xfrm>
-          <a:prstGeom xmlns:a="http://schemas.openxmlformats.org/drawingml/2006/main" prst="rect">
-            <a:avLst/>
-          </a:prstGeom>
-          <a:noFill xmlns:a="http://schemas.openxmlformats.org/drawingml/2006/main"/>
-          <a:ln xmlns:a="http://schemas.openxmlformats.org/drawingml/2006/main" w="0">
-            <a:noFill/>
-          </a:ln>
-        </p:spPr>
-        <p:txBody>
-          <a:bodyPr xmlns:a="http://schemas.openxmlformats.org/drawingml/2006/main" wrap="square" lIns="0" tIns="0" rIns="0" bIns="0" anchor="t"/>
-          <a:lstStyle xmlns:a="http://schemas.openxmlformats.org/drawingml/2006/main"/>
-          <a:p xmlns:a="http://schemas.openxmlformats.org/drawingml/2006/main">
-            <a:r>
-              <a:rPr lang="en-US" sz="1050">
+              <a:t>31m</a:t>
+            </a:r>
+            <a:endParaRPr lang="en-US"/>
+          </a:p>
+        </p:txBody>
+      </p:sp>
+      <p:sp>
+        <p:nvSpPr>
+          <p:cNvPr id="11" name="blue-flame-kpi-label-1"/>
+          <p:cNvSpPr txBox="1"/>
+          <p:nvPr/>
+        </p:nvSpPr>
+        <p:spPr>
+          <a:xfrm xmlns:a="http://schemas.openxmlformats.org/drawingml/2006/main">
+            <a:off x="3524250" y="2457450"/>
+            <a:ext cx="2000250" cy="190500"/>
+          </a:xfrm>
+          <a:prstGeom xmlns:a="http://schemas.openxmlformats.org/drawingml/2006/main" prst="rect">
+            <a:avLst/>
+          </a:prstGeom>
+          <a:noFill xmlns:a="http://schemas.openxmlformats.org/drawingml/2006/main"/>
+          <a:ln xmlns:a="http://schemas.openxmlformats.org/drawingml/2006/main" w="0">
+            <a:noFill/>
+          </a:ln>
+        </p:spPr>
+        <p:txBody>
+          <a:bodyPr xmlns:a="http://schemas.openxmlformats.org/drawingml/2006/main" wrap="square" lIns="0" tIns="0" rIns="0" bIns="0" anchor="t"/>
+          <a:lstStyle xmlns:a="http://schemas.openxmlformats.org/drawingml/2006/main"/>
+          <a:p xmlns:a="http://schemas.openxmlformats.org/drawingml/2006/main">
+            <a:r>
+              <a:rPr lang="en-US" sz="975">
                 <a:solidFill>
                   <a:srgbClr val="787B7F"/>
                 </a:solidFill>
                 <a:latin typeface="Inter"/>
                 <a:ea typeface="Inter"/>
               </a:rPr>
-              <a:t>OfficeKit original clean-room calibration · fictional content · 2026-08-29</a:t>
-            </a:r>
-            <a:endParaRPr lang="en-US"/>
-          </a:p>
-        </p:txBody>
-      </p:sp>
-      <p:sp>
-        <p:nvSpPr>
-          <p:cNvPr id="22" name="page-number"/>
-          <p:cNvSpPr txBox="1"/>
-          <p:nvPr/>
-        </p:nvSpPr>
-        <p:spPr>
-          <a:xfrm xmlns:a="http://schemas.openxmlformats.org/drawingml/2006/main">
-            <a:off x="13335000" y="7810500"/>
-            <a:ext cx="952500" cy="209550"/>
-          </a:xfrm>
-          <a:prstGeom xmlns:a="http://schemas.openxmlformats.org/drawingml/2006/main" prst="rect">
-            <a:avLst/>
-          </a:prstGeom>
-          <a:noFill xmlns:a="http://schemas.openxmlformats.org/drawingml/2006/main"/>
-          <a:ln xmlns:a="http://schemas.openxmlformats.org/drawingml/2006/main" w="0">
-            <a:noFill/>
-          </a:ln>
-        </p:spPr>
-        <p:txBody>
-          <a:bodyPr xmlns:a="http://schemas.openxmlformats.org/drawingml/2006/main" wrap="square" lIns="0" tIns="0" rIns="0" bIns="0" anchor="t"/>
-          <a:lstStyle xmlns:a="http://schemas.openxmlformats.org/drawingml/2006/main"/>
-          <a:p xmlns:a="http://schemas.openxmlformats.org/drawingml/2006/main">
-            <a:pPr algn="r"/>
-            <a:r>
-              <a:rPr lang="en-US" sz="1050">
-                <a:solidFill>
-                  <a:srgbClr val="787B7F"/>
-                </a:solidFill>
-                <a:latin typeface="Inter"/>
-                <a:ea typeface="Inter"/>
-              </a:rPr>
-              <a:t>1 / 6</a:t>
-            </a:r>
-            <a:endParaRPr lang="en-US"/>
-          </a:p>
-        </p:txBody>
-      </p:sp>
-      <p:sp>
-        <p:nvSpPr>
-          <p:cNvPr id="23" name="anchor-field"/>
+              <a:t>avg. handoff</a:t>
+            </a:r>
+            <a:endParaRPr lang="en-US"/>
+          </a:p>
+        </p:txBody>
+      </p:sp>
+      <p:sp>
+        <p:nvSpPr>
+          <p:cNvPr id="12" name="blue-flame-kpi-rule-1"/>
           <p:cNvSpPr/>
           <p:nvPr/>
         </p:nvSpPr>
         <p:spPr>
           <a:xfrm xmlns:a="http://schemas.openxmlformats.org/drawingml/2006/main">
-            <a:off x="11620500" y="1790700"/>
-            <a:ext cx="2095500" cy="2286000"/>
-          </a:xfrm>
-          <a:prstGeom xmlns:a="http://schemas.openxmlformats.org/drawingml/2006/main" prst="rect">
-            <a:avLst/>
-          </a:prstGeom>
-          <a:solidFill xmlns:a="http://schemas.openxmlformats.org/drawingml/2006/main">
-            <a:srgbClr val="131A24"/>
-          </a:solidFill>
-          <a:ln xmlns:a="http://schemas.openxmlformats.org/drawingml/2006/main" w="25400">
+            <a:off x="5734050" y="2038350"/>
+            <a:ext cx="0" cy="609600"/>
+          </a:xfrm>
+          <a:prstGeom xmlns:a="http://schemas.openxmlformats.org/drawingml/2006/main" prst="line">
+            <a:avLst/>
+          </a:prstGeom>
+          <a:noFill xmlns:a="http://schemas.openxmlformats.org/drawingml/2006/main"/>
+          <a:ln xmlns:a="http://schemas.openxmlformats.org/drawingml/2006/main" w="12700">
             <a:solidFill>
-              <a:srgbClr val="20BBD8"/>
+              <a:srgbClr val="787B7F"/>
             </a:solidFill>
             <a:prstDash val="solid"/>
           </a:ln>
@@ -1031,21 +610,116 @@
       </p:sp>
       <p:sp>
         <p:nvSpPr>
-          <p:cNvPr id="24" name="anchor-grid-0-0"/>
+          <p:cNvPr id="13" name="blue-flame-kpi-value-2"/>
+          <p:cNvSpPr txBox="1"/>
+          <p:nvPr/>
+        </p:nvSpPr>
+        <p:spPr>
+          <a:xfrm xmlns:a="http://schemas.openxmlformats.org/drawingml/2006/main">
+            <a:off x="6096000" y="2076450"/>
+            <a:ext cx="2000250" cy="361950"/>
+          </a:xfrm>
+          <a:prstGeom xmlns:a="http://schemas.openxmlformats.org/drawingml/2006/main" prst="rect">
+            <a:avLst/>
+          </a:prstGeom>
+          <a:noFill xmlns:a="http://schemas.openxmlformats.org/drawingml/2006/main"/>
+          <a:ln xmlns:a="http://schemas.openxmlformats.org/drawingml/2006/main" w="0">
+            <a:noFill/>
+          </a:ln>
+        </p:spPr>
+        <p:txBody>
+          <a:bodyPr xmlns:a="http://schemas.openxmlformats.org/drawingml/2006/main" wrap="square" lIns="0" tIns="0" rIns="0" bIns="0" anchor="t"/>
+          <a:lstStyle xmlns:a="http://schemas.openxmlformats.org/drawingml/2006/main"/>
+          <a:p xmlns:a="http://schemas.openxmlformats.org/drawingml/2006/main">
+            <a:r>
+              <a:rPr lang="en-US" sz="2100" b="1">
+                <a:solidFill>
+                  <a:srgbClr val="20BBD8"/>
+                </a:solidFill>
+                <a:latin typeface="Inter"/>
+                <a:ea typeface="Inter"/>
+              </a:rPr>
+              <a:t>5.1m</a:t>
+            </a:r>
+            <a:endParaRPr lang="en-US"/>
+          </a:p>
+        </p:txBody>
+      </p:sp>
+      <p:sp>
+        <p:nvSpPr>
+          <p:cNvPr id="14" name="blue-flame-kpi-label-2"/>
+          <p:cNvSpPr txBox="1"/>
+          <p:nvPr/>
+        </p:nvSpPr>
+        <p:spPr>
+          <a:xfrm xmlns:a="http://schemas.openxmlformats.org/drawingml/2006/main">
+            <a:off x="6096000" y="2457450"/>
+            <a:ext cx="2000250" cy="190500"/>
+          </a:xfrm>
+          <a:prstGeom xmlns:a="http://schemas.openxmlformats.org/drawingml/2006/main" prst="rect">
+            <a:avLst/>
+          </a:prstGeom>
+          <a:noFill xmlns:a="http://schemas.openxmlformats.org/drawingml/2006/main"/>
+          <a:ln xmlns:a="http://schemas.openxmlformats.org/drawingml/2006/main" w="0">
+            <a:noFill/>
+          </a:ln>
+        </p:spPr>
+        <p:txBody>
+          <a:bodyPr xmlns:a="http://schemas.openxmlformats.org/drawingml/2006/main" wrap="square" lIns="0" tIns="0" rIns="0" bIns="0" anchor="t"/>
+          <a:lstStyle xmlns:a="http://schemas.openxmlformats.org/drawingml/2006/main"/>
+          <a:p xmlns:a="http://schemas.openxmlformats.org/drawingml/2006/main">
+            <a:r>
+              <a:rPr lang="en-US" sz="975">
+                <a:solidFill>
+                  <a:srgbClr val="787B7F"/>
+                </a:solidFill>
+                <a:latin typeface="Inter"/>
+                <a:ea typeface="Inter"/>
+              </a:rPr>
+              <a:t>cost variance</a:t>
+            </a:r>
+            <a:endParaRPr lang="en-US"/>
+          </a:p>
+        </p:txBody>
+      </p:sp>
+      <p:pic>
+        <p:nvPicPr>
+          <p:cNvPr id="15" name="blue-flame-cover-photo" descr="Documentary operating scene used as the cover evidence band"/>
+          <p:cNvPicPr/>
+          <p:nvPr/>
+        </p:nvPicPr>
+        <p:blipFill>
+          <a:blip xmlns:r="http://schemas.openxmlformats.org/officeDocument/2006/relationships" xmlns:a="http://schemas.openxmlformats.org/drawingml/2006/main" r:embed="rIdOfficeKitImage0d3bd4b5ccdd7cbb_1"/>
+          <a:srcRect xmlns:a="http://schemas.openxmlformats.org/drawingml/2006/main" l="0" t="45645" r="0" b="45645"/>
+          <a:stretch xmlns:a="http://schemas.openxmlformats.org/drawingml/2006/main">
+            <a:fillRect/>
+          </a:stretch>
+        </p:blipFill>
+        <p:spPr>
+          <a:xfrm xmlns:a="http://schemas.openxmlformats.org/drawingml/2006/main">
+            <a:off x="914400" y="3105150"/>
+            <a:ext cx="13411200" cy="2076450"/>
+          </a:xfrm>
+          <a:prstGeom xmlns:a="http://schemas.openxmlformats.org/drawingml/2006/main" prst="rect">
+            <a:avLst/>
+          </a:prstGeom>
+        </p:spPr>
+      </p:pic>
+      <p:sp>
+        <p:nvSpPr>
+          <p:cNvPr id="16" name="blue-flame-photo-frame"/>
           <p:cNvSpPr/>
           <p:nvPr/>
         </p:nvSpPr>
         <p:spPr>
           <a:xfrm xmlns:a="http://schemas.openxmlformats.org/drawingml/2006/main">
-            <a:off x="11925300" y="2152650"/>
-            <a:ext cx="266700" cy="285750"/>
-          </a:xfrm>
-          <a:prstGeom xmlns:a="http://schemas.openxmlformats.org/drawingml/2006/main" prst="rect">
-            <a:avLst/>
-          </a:prstGeom>
-          <a:solidFill xmlns:a="http://schemas.openxmlformats.org/drawingml/2006/main">
-            <a:srgbClr val="20BBD8"/>
-          </a:solidFill>
+            <a:off x="914400" y="3105150"/>
+            <a:ext cx="13411200" cy="2076450"/>
+          </a:xfrm>
+          <a:prstGeom xmlns:a="http://schemas.openxmlformats.org/drawingml/2006/main" prst="rect">
+            <a:avLst/>
+          </a:prstGeom>
+          <a:noFill xmlns:a="http://schemas.openxmlformats.org/drawingml/2006/main"/>
           <a:ln xmlns:a="http://schemas.openxmlformats.org/drawingml/2006/main" w="12700">
             <a:solidFill>
               <a:srgbClr val="20BBD8"/>
@@ -1067,24 +741,22 @@
       </p:sp>
       <p:sp>
         <p:nvSpPr>
-          <p:cNvPr id="25" name="anchor-grid-0-1"/>
+          <p:cNvPr id="17" name="blue-flame-cover-footer-rule"/>
           <p:cNvSpPr/>
           <p:nvPr/>
         </p:nvSpPr>
         <p:spPr>
           <a:xfrm xmlns:a="http://schemas.openxmlformats.org/drawingml/2006/main">
-            <a:off x="12420600" y="2152650"/>
-            <a:ext cx="266700" cy="285750"/>
-          </a:xfrm>
-          <a:prstGeom xmlns:a="http://schemas.openxmlformats.org/drawingml/2006/main" prst="rect">
-            <a:avLst/>
-          </a:prstGeom>
-          <a:solidFill xmlns:a="http://schemas.openxmlformats.org/drawingml/2006/main">
-            <a:srgbClr val="20BBD8"/>
-          </a:solidFill>
+            <a:off x="914400" y="6553200"/>
+            <a:ext cx="13411200" cy="0"/>
+          </a:xfrm>
+          <a:prstGeom xmlns:a="http://schemas.openxmlformats.org/drawingml/2006/main" prst="line">
+            <a:avLst/>
+          </a:prstGeom>
+          <a:noFill xmlns:a="http://schemas.openxmlformats.org/drawingml/2006/main"/>
           <a:ln xmlns:a="http://schemas.openxmlformats.org/drawingml/2006/main" w="12700">
             <a:solidFill>
-              <a:srgbClr val="20BBD8"/>
+              <a:srgbClr val="787B7F"/>
             </a:solidFill>
             <a:prstDash val="solid"/>
           </a:ln>
@@ -1103,285 +775,111 @@
       </p:sp>
       <p:sp>
         <p:nvSpPr>
-          <p:cNvPr id="26" name="anchor-grid-0-2"/>
-          <p:cNvSpPr/>
-          <p:nvPr/>
-        </p:nvSpPr>
-        <p:spPr>
-          <a:xfrm xmlns:a="http://schemas.openxmlformats.org/drawingml/2006/main">
-            <a:off x="12915900" y="2152650"/>
-            <a:ext cx="266700" cy="285750"/>
-          </a:xfrm>
-          <a:prstGeom xmlns:a="http://schemas.openxmlformats.org/drawingml/2006/main" prst="rect">
-            <a:avLst/>
-          </a:prstGeom>
-          <a:solidFill xmlns:a="http://schemas.openxmlformats.org/drawingml/2006/main">
-            <a:srgbClr val="070A10"/>
-          </a:solidFill>
-          <a:ln xmlns:a="http://schemas.openxmlformats.org/drawingml/2006/main" w="12700">
-            <a:solidFill>
-              <a:srgbClr val="20BBD8"/>
-            </a:solidFill>
-            <a:prstDash val="solid"/>
-          </a:ln>
-        </p:spPr>
-        <p:txBody>
-          <a:bodyPr xmlns:a="http://schemas.openxmlformats.org/drawingml/2006/main" wrap="square" lIns="0" tIns="0" rIns="0" bIns="0" anchor="t"/>
-          <a:lstStyle xmlns:a="http://schemas.openxmlformats.org/drawingml/2006/main"/>
-          <a:p xmlns:a="http://schemas.openxmlformats.org/drawingml/2006/main">
-            <a:r>
-              <a:rPr lang="en-US"/>
-              <a:t/>
-            </a:r>
-            <a:endParaRPr lang="en-US"/>
-          </a:p>
-        </p:txBody>
-      </p:sp>
-      <p:sp>
-        <p:nvSpPr>
-          <p:cNvPr id="27" name="anchor-grid-1-0"/>
-          <p:cNvSpPr/>
-          <p:nvPr/>
-        </p:nvSpPr>
-        <p:spPr>
-          <a:xfrm xmlns:a="http://schemas.openxmlformats.org/drawingml/2006/main">
-            <a:off x="11925300" y="2686050"/>
-            <a:ext cx="266700" cy="285750"/>
-          </a:xfrm>
-          <a:prstGeom xmlns:a="http://schemas.openxmlformats.org/drawingml/2006/main" prst="rect">
-            <a:avLst/>
-          </a:prstGeom>
-          <a:solidFill xmlns:a="http://schemas.openxmlformats.org/drawingml/2006/main">
-            <a:srgbClr val="20BBD8"/>
-          </a:solidFill>
-          <a:ln xmlns:a="http://schemas.openxmlformats.org/drawingml/2006/main" w="12700">
-            <a:solidFill>
-              <a:srgbClr val="20BBD8"/>
-            </a:solidFill>
-            <a:prstDash val="solid"/>
-          </a:ln>
-        </p:spPr>
-        <p:txBody>
-          <a:bodyPr xmlns:a="http://schemas.openxmlformats.org/drawingml/2006/main" wrap="square" lIns="0" tIns="0" rIns="0" bIns="0" anchor="t"/>
-          <a:lstStyle xmlns:a="http://schemas.openxmlformats.org/drawingml/2006/main"/>
-          <a:p xmlns:a="http://schemas.openxmlformats.org/drawingml/2006/main">
-            <a:r>
-              <a:rPr lang="en-US"/>
-              <a:t/>
-            </a:r>
-            <a:endParaRPr lang="en-US"/>
-          </a:p>
-        </p:txBody>
-      </p:sp>
-      <p:sp>
-        <p:nvSpPr>
-          <p:cNvPr id="28" name="anchor-grid-1-1"/>
-          <p:cNvSpPr/>
-          <p:nvPr/>
-        </p:nvSpPr>
-        <p:spPr>
-          <a:xfrm xmlns:a="http://schemas.openxmlformats.org/drawingml/2006/main">
-            <a:off x="12420600" y="2686050"/>
-            <a:ext cx="266700" cy="285750"/>
-          </a:xfrm>
-          <a:prstGeom xmlns:a="http://schemas.openxmlformats.org/drawingml/2006/main" prst="rect">
-            <a:avLst/>
-          </a:prstGeom>
-          <a:solidFill xmlns:a="http://schemas.openxmlformats.org/drawingml/2006/main">
-            <a:srgbClr val="20BBD8"/>
-          </a:solidFill>
-          <a:ln xmlns:a="http://schemas.openxmlformats.org/drawingml/2006/main" w="12700">
-            <a:solidFill>
-              <a:srgbClr val="20BBD8"/>
-            </a:solidFill>
-            <a:prstDash val="solid"/>
-          </a:ln>
-        </p:spPr>
-        <p:txBody>
-          <a:bodyPr xmlns:a="http://schemas.openxmlformats.org/drawingml/2006/main" wrap="square" lIns="0" tIns="0" rIns="0" bIns="0" anchor="t"/>
-          <a:lstStyle xmlns:a="http://schemas.openxmlformats.org/drawingml/2006/main"/>
-          <a:p xmlns:a="http://schemas.openxmlformats.org/drawingml/2006/main">
-            <a:r>
-              <a:rPr lang="en-US"/>
-              <a:t/>
-            </a:r>
-            <a:endParaRPr lang="en-US"/>
-          </a:p>
-        </p:txBody>
-      </p:sp>
-      <p:sp>
-        <p:nvSpPr>
-          <p:cNvPr id="29" name="anchor-grid-1-2"/>
-          <p:cNvSpPr/>
-          <p:nvPr/>
-        </p:nvSpPr>
-        <p:spPr>
-          <a:xfrm xmlns:a="http://schemas.openxmlformats.org/drawingml/2006/main">
-            <a:off x="12915900" y="2686050"/>
-            <a:ext cx="266700" cy="285750"/>
-          </a:xfrm>
-          <a:prstGeom xmlns:a="http://schemas.openxmlformats.org/drawingml/2006/main" prst="rect">
-            <a:avLst/>
-          </a:prstGeom>
-          <a:solidFill xmlns:a="http://schemas.openxmlformats.org/drawingml/2006/main">
-            <a:srgbClr val="070A10"/>
-          </a:solidFill>
-          <a:ln xmlns:a="http://schemas.openxmlformats.org/drawingml/2006/main" w="12700">
-            <a:solidFill>
-              <a:srgbClr val="20BBD8"/>
-            </a:solidFill>
-            <a:prstDash val="solid"/>
-          </a:ln>
-        </p:spPr>
-        <p:txBody>
-          <a:bodyPr xmlns:a="http://schemas.openxmlformats.org/drawingml/2006/main" wrap="square" lIns="0" tIns="0" rIns="0" bIns="0" anchor="t"/>
-          <a:lstStyle xmlns:a="http://schemas.openxmlformats.org/drawingml/2006/main"/>
-          <a:p xmlns:a="http://schemas.openxmlformats.org/drawingml/2006/main">
-            <a:r>
-              <a:rPr lang="en-US"/>
-              <a:t/>
-            </a:r>
-            <a:endParaRPr lang="en-US"/>
-          </a:p>
-        </p:txBody>
-      </p:sp>
-      <p:sp>
-        <p:nvSpPr>
-          <p:cNvPr id="30" name="anchor-grid-2-0"/>
-          <p:cNvSpPr/>
-          <p:nvPr/>
-        </p:nvSpPr>
-        <p:spPr>
-          <a:xfrm xmlns:a="http://schemas.openxmlformats.org/drawingml/2006/main">
-            <a:off x="11925300" y="3219450"/>
-            <a:ext cx="266700" cy="285750"/>
-          </a:xfrm>
-          <a:prstGeom xmlns:a="http://schemas.openxmlformats.org/drawingml/2006/main" prst="rect">
-            <a:avLst/>
-          </a:prstGeom>
-          <a:solidFill xmlns:a="http://schemas.openxmlformats.org/drawingml/2006/main">
-            <a:srgbClr val="20BBD8"/>
-          </a:solidFill>
-          <a:ln xmlns:a="http://schemas.openxmlformats.org/drawingml/2006/main" w="12700">
-            <a:solidFill>
-              <a:srgbClr val="20BBD8"/>
-            </a:solidFill>
-            <a:prstDash val="solid"/>
-          </a:ln>
-        </p:spPr>
-        <p:txBody>
-          <a:bodyPr xmlns:a="http://schemas.openxmlformats.org/drawingml/2006/main" wrap="square" lIns="0" tIns="0" rIns="0" bIns="0" anchor="t"/>
-          <a:lstStyle xmlns:a="http://schemas.openxmlformats.org/drawingml/2006/main"/>
-          <a:p xmlns:a="http://schemas.openxmlformats.org/drawingml/2006/main">
-            <a:r>
-              <a:rPr lang="en-US"/>
-              <a:t/>
-            </a:r>
-            <a:endParaRPr lang="en-US"/>
-          </a:p>
-        </p:txBody>
-      </p:sp>
-      <p:sp>
-        <p:nvSpPr>
-          <p:cNvPr id="31" name="anchor-grid-2-1"/>
-          <p:cNvSpPr/>
-          <p:nvPr/>
-        </p:nvSpPr>
-        <p:spPr>
-          <a:xfrm xmlns:a="http://schemas.openxmlformats.org/drawingml/2006/main">
-            <a:off x="12420600" y="3219450"/>
-            <a:ext cx="266700" cy="285750"/>
-          </a:xfrm>
-          <a:prstGeom xmlns:a="http://schemas.openxmlformats.org/drawingml/2006/main" prst="rect">
-            <a:avLst/>
-          </a:prstGeom>
-          <a:solidFill xmlns:a="http://schemas.openxmlformats.org/drawingml/2006/main">
-            <a:srgbClr val="20BBD8"/>
-          </a:solidFill>
-          <a:ln xmlns:a="http://schemas.openxmlformats.org/drawingml/2006/main" w="12700">
-            <a:solidFill>
-              <a:srgbClr val="20BBD8"/>
-            </a:solidFill>
-            <a:prstDash val="solid"/>
-          </a:ln>
-        </p:spPr>
-        <p:txBody>
-          <a:bodyPr xmlns:a="http://schemas.openxmlformats.org/drawingml/2006/main" wrap="square" lIns="0" tIns="0" rIns="0" bIns="0" anchor="t"/>
-          <a:lstStyle xmlns:a="http://schemas.openxmlformats.org/drawingml/2006/main"/>
-          <a:p xmlns:a="http://schemas.openxmlformats.org/drawingml/2006/main">
-            <a:r>
-              <a:rPr lang="en-US"/>
-              <a:t/>
-            </a:r>
-            <a:endParaRPr lang="en-US"/>
-          </a:p>
-        </p:txBody>
-      </p:sp>
-      <p:sp>
-        <p:nvSpPr>
-          <p:cNvPr id="32" name="anchor-grid-2-2"/>
-          <p:cNvSpPr/>
-          <p:nvPr/>
-        </p:nvSpPr>
-        <p:spPr>
-          <a:xfrm xmlns:a="http://schemas.openxmlformats.org/drawingml/2006/main">
-            <a:off x="12915900" y="3219450"/>
-            <a:ext cx="266700" cy="285750"/>
-          </a:xfrm>
-          <a:prstGeom xmlns:a="http://schemas.openxmlformats.org/drawingml/2006/main" prst="rect">
-            <a:avLst/>
-          </a:prstGeom>
-          <a:solidFill xmlns:a="http://schemas.openxmlformats.org/drawingml/2006/main">
-            <a:srgbClr val="070A10"/>
-          </a:solidFill>
-          <a:ln xmlns:a="http://schemas.openxmlformats.org/drawingml/2006/main" w="12700">
-            <a:solidFill>
-              <a:srgbClr val="20BBD8"/>
-            </a:solidFill>
-            <a:prstDash val="solid"/>
-          </a:ln>
-        </p:spPr>
-        <p:txBody>
-          <a:bodyPr xmlns:a="http://schemas.openxmlformats.org/drawingml/2006/main" wrap="square" lIns="0" tIns="0" rIns="0" bIns="0" anchor="t"/>
-          <a:lstStyle xmlns:a="http://schemas.openxmlformats.org/drawingml/2006/main"/>
-          <a:p xmlns:a="http://schemas.openxmlformats.org/drawingml/2006/main">
-            <a:r>
-              <a:rPr lang="en-US"/>
-              <a:t/>
-            </a:r>
-            <a:endParaRPr lang="en-US"/>
-          </a:p>
-        </p:txBody>
-      </p:sp>
-      <p:sp>
-        <p:nvSpPr>
-          <p:cNvPr id="33" name="anchor-axis"/>
-          <p:cNvSpPr/>
-          <p:nvPr/>
-        </p:nvSpPr>
-        <p:spPr>
-          <a:xfrm xmlns:a="http://schemas.openxmlformats.org/drawingml/2006/main">
-            <a:off x="12668250" y="1638300"/>
-            <a:ext cx="0" cy="2743200"/>
-          </a:xfrm>
-          <a:prstGeom xmlns:a="http://schemas.openxmlformats.org/drawingml/2006/main" prst="line">
-            <a:avLst/>
-          </a:prstGeom>
-          <a:noFill xmlns:a="http://schemas.openxmlformats.org/drawingml/2006/main"/>
-          <a:ln xmlns:a="http://schemas.openxmlformats.org/drawingml/2006/main" w="50800">
-            <a:solidFill>
-              <a:srgbClr val="F2F6F8"/>
-            </a:solidFill>
-            <a:prstDash val="solid"/>
-          </a:ln>
-        </p:spPr>
-        <p:txBody>
-          <a:bodyPr xmlns:a="http://schemas.openxmlformats.org/drawingml/2006/main" wrap="square" lIns="0" tIns="0" rIns="0" bIns="0" anchor="t"/>
-          <a:lstStyle xmlns:a="http://schemas.openxmlformats.org/drawingml/2006/main"/>
-          <a:p xmlns:a="http://schemas.openxmlformats.org/drawingml/2006/main">
-            <a:r>
-              <a:rPr lang="en-US"/>
-              <a:t/>
+          <p:cNvPr id="18" name="blue-flame-cover-thesis"/>
+          <p:cNvSpPr txBox="1"/>
+          <p:nvPr/>
+        </p:nvSpPr>
+        <p:spPr>
+          <a:xfrm xmlns:a="http://schemas.openxmlformats.org/drawingml/2006/main">
+            <a:off x="914400" y="6800850"/>
+            <a:ext cx="10096500" cy="285750"/>
+          </a:xfrm>
+          <a:prstGeom xmlns:a="http://schemas.openxmlformats.org/drawingml/2006/main" prst="rect">
+            <a:avLst/>
+          </a:prstGeom>
+          <a:noFill xmlns:a="http://schemas.openxmlformats.org/drawingml/2006/main"/>
+          <a:ln xmlns:a="http://schemas.openxmlformats.org/drawingml/2006/main" w="0">
+            <a:noFill/>
+          </a:ln>
+        </p:spPr>
+        <p:txBody>
+          <a:bodyPr xmlns:a="http://schemas.openxmlformats.org/drawingml/2006/main" wrap="square" lIns="0" tIns="0" rIns="0" bIns="0" anchor="t"/>
+          <a:lstStyle xmlns:a="http://schemas.openxmlformats.org/drawingml/2006/main"/>
+          <a:p xmlns:a="http://schemas.openxmlformats.org/drawingml/2006/main">
+            <a:r>
+              <a:rPr lang="en-US" sz="1575" b="1">
+                <a:solidFill>
+                  <a:srgbClr val="F2F6F8"/>
+                </a:solidFill>
+                <a:latin typeface="Inter"/>
+                <a:ea typeface="Inter"/>
+              </a:rPr>
+              <a:t>A visible operating signal creates a shared next action.</a:t>
+            </a:r>
+            <a:endParaRPr lang="en-US"/>
+          </a:p>
+        </p:txBody>
+      </p:sp>
+      <p:sp>
+        <p:nvSpPr>
+          <p:cNvPr id="19" name="blue-flame-cover-source"/>
+          <p:cNvSpPr txBox="1"/>
+          <p:nvPr/>
+        </p:nvSpPr>
+        <p:spPr>
+          <a:xfrm xmlns:a="http://schemas.openxmlformats.org/drawingml/2006/main">
+            <a:off x="914400" y="7829550"/>
+            <a:ext cx="10953750" cy="209550"/>
+          </a:xfrm>
+          <a:prstGeom xmlns:a="http://schemas.openxmlformats.org/drawingml/2006/main" prst="rect">
+            <a:avLst/>
+          </a:prstGeom>
+          <a:noFill xmlns:a="http://schemas.openxmlformats.org/drawingml/2006/main"/>
+          <a:ln xmlns:a="http://schemas.openxmlformats.org/drawingml/2006/main" w="0">
+            <a:noFill/>
+          </a:ln>
+        </p:spPr>
+        <p:txBody>
+          <a:bodyPr xmlns:a="http://schemas.openxmlformats.org/drawingml/2006/main" wrap="square" lIns="0" tIns="0" rIns="0" bIns="0" anchor="t"/>
+          <a:lstStyle xmlns:a="http://schemas.openxmlformats.org/drawingml/2006/main"/>
+          <a:p xmlns:a="http://schemas.openxmlformats.org/drawingml/2006/main">
+            <a:r>
+              <a:rPr lang="en-US" sz="1050">
+                <a:solidFill>
+                  <a:srgbClr val="787B7F"/>
+                </a:solidFill>
+                <a:latin typeface="Inter"/>
+                <a:ea typeface="Inter"/>
+              </a:rPr>
+              <a:t>OfficeKit original clean-room calibration · fictional content · 2026-08-29</a:t>
+            </a:r>
+            <a:endParaRPr lang="en-US"/>
+          </a:p>
+        </p:txBody>
+      </p:sp>
+      <p:sp>
+        <p:nvSpPr>
+          <p:cNvPr id="20" name="blue-flame-cover-page-number"/>
+          <p:cNvSpPr txBox="1"/>
+          <p:nvPr/>
+        </p:nvSpPr>
+        <p:spPr>
+          <a:xfrm xmlns:a="http://schemas.openxmlformats.org/drawingml/2006/main">
+            <a:off x="13335000" y="7829550"/>
+            <a:ext cx="952500" cy="209550"/>
+          </a:xfrm>
+          <a:prstGeom xmlns:a="http://schemas.openxmlformats.org/drawingml/2006/main" prst="rect">
+            <a:avLst/>
+          </a:prstGeom>
+          <a:noFill xmlns:a="http://schemas.openxmlformats.org/drawingml/2006/main"/>
+          <a:ln xmlns:a="http://schemas.openxmlformats.org/drawingml/2006/main" w="0">
+            <a:noFill/>
+          </a:ln>
+        </p:spPr>
+        <p:txBody>
+          <a:bodyPr xmlns:a="http://schemas.openxmlformats.org/drawingml/2006/main" wrap="square" lIns="0" tIns="0" rIns="0" bIns="0" anchor="t"/>
+          <a:lstStyle xmlns:a="http://schemas.openxmlformats.org/drawingml/2006/main"/>
+          <a:p xmlns:a="http://schemas.openxmlformats.org/drawingml/2006/main">
+            <a:pPr algn="r"/>
+            <a:r>
+              <a:rPr lang="en-US" sz="1050">
+                <a:solidFill>
+                  <a:srgbClr val="787B7F"/>
+                </a:solidFill>
+                <a:latin typeface="Inter"/>
+                <a:ea typeface="Inter"/>
+              </a:rPr>
+              <a:t>1 / 6</a:t>
             </a:r>
             <a:endParaRPr lang="en-US"/>
           </a:p>

</xml_diff>